<commit_message>
Deck: fill artefact and pre-registration slides with results
Slide 8 carries the artefact-control numbers with their reading (most
accuracy survives; losses do not follow muscle removal; seven participants
fall short of proof), since bare numbers would invite the wrong conclusion.
Slide 12 shows both registered predictions confirmed. Computed differences now
use a true minus sign to match the typed values.

Co-Authored-By: Claude Opus 5 (1M context) <noreply@anthropic.com>
</commit_message>
<xml_diff>
--- a/presentation/Updated_manuscript_presentation.pptx
+++ b/presentation/Updated_manuscript_presentation.pptx
@@ -4287,7 +4287,7 @@
                           </a:solidFill>
                           <a:latin typeface="Times New Roman"/>
                         </a:rPr>
-                        <a:t>pending</a:t>
+                        <a:t>+0.002</a:t>
                       </a:r>
                     </a:p>
                   </a:txBody>
@@ -4308,7 +4308,7 @@
                           </a:solidFill>
                           <a:latin typeface="Times New Roman"/>
                         </a:rPr>
-                        <a:t>pending</a:t>
+                        <a:t>Confirmed</a:t>
                       </a:r>
                     </a:p>
                   </a:txBody>
@@ -4373,7 +4373,7 @@
                           </a:solidFill>
                           <a:latin typeface="Times New Roman"/>
                         </a:rPr>
-                        <a:t>pending</a:t>
+                        <a:t>−0.006</a:t>
                       </a:r>
                     </a:p>
                   </a:txBody>
@@ -4394,7 +4394,7 @@
                           </a:solidFill>
                           <a:latin typeface="Times New Roman"/>
                         </a:rPr>
-                        <a:t>pending</a:t>
+                        <a:t>Confirmed</a:t>
                       </a:r>
                     </a:p>
                   </a:txBody>
@@ -4604,7 +4604,7 @@
                 </a:solidFill>
                 <a:latin typeface="Times New Roman"/>
               </a:rPr>
-              <a:t>Running overnight. Verdicts fill in when the runs finish.</a:t>
+              <a:t>Paired over 20 participants. Direction counts and Wilcoxon tests are reported but do not change the verdict.</a:t>
             </a:r>
           </a:p>
         </p:txBody>
@@ -9527,17 +9527,156 @@
                 <a:spcPct val="110000"/>
               </a:lnSpc>
               <a:spcAft>
+                <a:spcPts val="400"/>
+              </a:spcAft>
+            </a:pPr>
+            <a:r>
+              <a:rPr sz="1700" b="0" i="0">
+                <a:solidFill>
+                  <a:srgbClr val="555555"/>
+                </a:solidFill>
+                <a:latin typeface="Times New Roman"/>
+              </a:rPr>
+              <a:t>Uncleaned  </a:t>
+            </a:r>
+            <a:r>
+              <a:rPr sz="1700" b="1" i="0">
+                <a:solidFill>
+                  <a:srgbClr val="111111"/>
+                </a:solidFill>
+                <a:latin typeface="Times New Roman"/>
+              </a:rPr>
+              <a:t>0.835</a:t>
+            </a:r>
+            <a:r>
+              <a:rPr sz="1700" b="0" i="0">
+                <a:solidFill>
+                  <a:srgbClr val="555555"/>
+                </a:solidFill>
+                <a:latin typeface="Times New Roman"/>
+              </a:rPr>
+              <a:t>      Cleaned  </a:t>
+            </a:r>
+            <a:r>
+              <a:rPr sz="1700" b="1" i="0">
+                <a:solidFill>
+                  <a:srgbClr val="111111"/>
+                </a:solidFill>
+                <a:latin typeface="Times New Roman"/>
+              </a:rPr>
+              <a:t>0.785</a:t>
+            </a:r>
+          </a:p>
+          <a:p>
+            <a:pPr algn="l">
+              <a:lnSpc>
+                <a:spcPct val="110000"/>
+              </a:lnSpc>
+              <a:spcAft>
+                <a:spcPts val="1200"/>
+              </a:spcAft>
+            </a:pPr>
+            <a:r>
+              <a:rPr sz="1700" b="0" i="0">
+                <a:solidFill>
+                  <a:srgbClr val="555555"/>
+                </a:solidFill>
+                <a:latin typeface="Times New Roman"/>
+              </a:rPr>
+              <a:t>Change  </a:t>
+            </a:r>
+            <a:r>
+              <a:rPr sz="1700" b="1" i="0">
+                <a:solidFill>
+                  <a:srgbClr val="111111"/>
+                </a:solidFill>
+                <a:latin typeface="Times New Roman"/>
+              </a:rPr>
+              <a:t>−0.051</a:t>
+            </a:r>
+            <a:r>
+              <a:rPr sz="1400" b="0" i="0">
+                <a:solidFill>
+                  <a:srgbClr val="555555"/>
+                </a:solidFill>
+                <a:latin typeface="Times New Roman"/>
+              </a:rPr>
+              <a:t>   p = 0.22, n = 7</a:t>
+            </a:r>
+          </a:p>
+          <a:p>
+            <a:pPr algn="l">
+              <a:lnSpc>
+                <a:spcPct val="120000"/>
+              </a:lnSpc>
+              <a:spcAft>
                 <a:spcPts val="800"/>
               </a:spcAft>
             </a:pPr>
             <a:r>
-              <a:rPr sz="1700" b="0" i="1">
+              <a:rPr sz="1500" b="1" i="0">
                 <a:solidFill>
                   <a:srgbClr val="111111"/>
                 </a:solidFill>
                 <a:latin typeface="Times New Roman"/>
               </a:rPr>
-              <a:t>Running overnight. Result pending.</a:t>
+              <a:t>Most accuracy survives. </a:t>
+            </a:r>
+            <a:r>
+              <a:rPr sz="1500" b="0" i="0">
+                <a:solidFill>
+                  <a:srgbClr val="555555"/>
+                </a:solidFill>
+                <a:latin typeface="Times New Roman"/>
+              </a:rPr>
+              <a:t>Four of seven participants are unchanged or improve.</a:t>
+            </a:r>
+          </a:p>
+          <a:p>
+            <a:pPr algn="l">
+              <a:lnSpc>
+                <a:spcPct val="120000"/>
+              </a:lnSpc>
+              <a:spcAft>
+                <a:spcPts val="800"/>
+              </a:spcAft>
+            </a:pPr>
+            <a:r>
+              <a:rPr sz="1500" b="1" i="0">
+                <a:solidFill>
+                  <a:srgbClr val="111111"/>
+                </a:solidFill>
+                <a:latin typeface="Times New Roman"/>
+              </a:rPr>
+              <a:t>Losses do not track muscle. </a:t>
+            </a:r>
+            <a:r>
+              <a:rPr sz="1500" b="0" i="0">
+                <a:solidFill>
+                  <a:srgbClr val="555555"/>
+                </a:solidFill>
+                <a:latin typeface="Times New Roman"/>
+              </a:rPr>
+              <a:t>The participant with the most muscle removed improves; one with almost none removed loses most.</a:t>
+            </a:r>
+          </a:p>
+          <a:p>
+            <a:pPr algn="l">
+              <a:lnSpc>
+                <a:spcPct val="115000"/>
+              </a:lnSpc>
+              <a:spcAft>
+                <a:spcPts val="800"/>
+              </a:spcAft>
+            </a:pPr>
+            <a:r>
+              <a:rPr sz="1300" b="0" i="1">
+                <a:solidFill>
+                  <a:srgbClr val="555555"/>
+                </a:solidFill>
+                <a:latin typeface="Times New Roman"/>
+              </a:rPr>
+              <a:t>Seven participants: evidence against muscle dependence, short of proof.</a:t>
             </a:r>
           </a:p>
         </p:txBody>

</xml_diff>

<commit_message>
Deck: selective-head card carries the align-only result
Co-Authored-By: Claude Opus 5 (1M context) <noreply@anthropic.com>
</commit_message>
<xml_diff>
--- a/presentation/Updated_manuscript_presentation.pptx
+++ b/presentation/Updated_manuscript_presentation.pptx
@@ -4814,7 +4814,7 @@
                 </a:solidFill>
                 <a:latin typeface="Times New Roman"/>
               </a:rPr>
-              <a:t>Abstention</a:t>
+              <a:t>The selective head</a:t>
             </a:r>
           </a:p>
           <a:p>
@@ -4833,7 +4833,7 @@
                 </a:solidFill>
                 <a:latin typeface="Times New Roman"/>
               </a:rPr>
-              <a:t>Declining uncertain windows lowers accuracy in 14 of 18 arms, by 0.045 on average. The trained gate ranks windows worse than no ranking at all.</a:t>
+              <a:t>Declining uncertain windows lowers accuracy in 14 of 18 arms. It adds no accuracy either: alignment alone reaches 0.883, with the head 0.884.</a:t>
             </a:r>
           </a:p>
         </p:txBody>

</xml_diff>

<commit_message>
Deck: slide 2 states the registered test held; slide 8 counts four lines of evidence
Co-Authored-By: Claude Opus 5 (1M context) <noreply@anthropic.com>
</commit_message>
<xml_diff>
--- a/presentation/Updated_manuscript_presentation.pptx
+++ b/presentation/Updated_manuscript_presentation.pptx
@@ -6515,7 +6515,7 @@
                 </a:solidFill>
                 <a:latin typeface="Times New Roman"/>
               </a:rPr>
-              <a:t>An independent second cohort, and a third cohort tested against a prediction registered before any model was trained.</a:t>
+              <a:t>An independent second cohort, and a third cohort tested against a prediction registered before any model was trained. Both predictions held.</a:t>
             </a:r>
           </a:p>
         </p:txBody>
@@ -9353,7 +9353,7 @@
                 </a:solidFill>
                 <a:latin typeface="Times New Roman"/>
               </a:rPr>
-              <a:t>Three separate lines of evidence</a:t>
+              <a:t>Four independent lines of evidence</a:t>
             </a:r>
           </a:p>
           <a:p>

</xml_diff>

<commit_message>
Deck: three-seed headline on slides 7 and 14
Co-Authored-By: Claude Opus 5 (1M context) <noreply@anthropic.com>
</commit_message>
<xml_diff>
--- a/presentation/Updated_manuscript_presentation.pptx
+++ b/presentation/Updated_manuscript_presentation.pptx
@@ -5255,7 +5255,7 @@
                 </a:solidFill>
                 <a:latin typeface="Times New Roman"/>
               </a:rPr>
-              <a:t>Headline ablation is a single seed.</a:t>
+              <a:t>Headline over three seeds is 0.868 ± 0.026; most other arms are single seed.</a:t>
             </a:r>
           </a:p>
           <a:p>
@@ -5409,7 +5409,7 @@
                 </a:solidFill>
                 <a:latin typeface="Times New Roman"/>
               </a:rPr>
-              <a:t>Multi-seed headline, about 47 GPU hours.</a:t>
+              <a:t>Three seeds for every ablation arm.</a:t>
             </a:r>
           </a:p>
           <a:p>
@@ -9144,26 +9144,54 @@
                 <a:spcPct val="125000"/>
               </a:lnSpc>
               <a:spcAft>
+                <a:spcPts val="1000"/>
+              </a:spcAft>
+            </a:pPr>
+            <a:r>
+              <a:rPr sz="1700" b="1" i="0">
+                <a:solidFill>
+                  <a:srgbClr val="111111"/>
+                </a:solidFill>
+                <a:latin typeface="Times New Roman"/>
+              </a:rPr>
+              <a:t>0.901 at 53 % of ATCNet's parameters. </a:t>
+            </a:r>
+            <a:r>
+              <a:rPr sz="1700" b="0" i="0">
+                <a:solidFill>
+                  <a:srgbClr val="555555"/>
+                </a:solidFill>
+                <a:latin typeface="Times New Roman"/>
+              </a:rPr>
+              <a:t>Removing alignment costs 0.074 on this cohort. Seven participants, nine sessions each, fitted on sessions 1–3 and tested on sessions 4–9 recorded weeks later.</a:t>
+            </a:r>
+          </a:p>
+          <a:p>
+            <a:pPr algn="l">
+              <a:lnSpc>
+                <a:spcPct val="120000"/>
+              </a:lnSpc>
+              <a:spcAft>
                 <a:spcPts val="800"/>
               </a:spcAft>
             </a:pPr>
             <a:r>
-              <a:rPr sz="1700" b="1" i="0">
+              <a:rPr sz="1600" b="1" i="0">
                 <a:solidFill>
                   <a:srgbClr val="111111"/>
                 </a:solidFill>
                 <a:latin typeface="Times New Roman"/>
               </a:rPr>
-              <a:t>0.901 at 53 % of ATCNet's parameters. </a:t>
-            </a:r>
-            <a:r>
-              <a:rPr sz="1700" b="0" i="0">
+              <a:t>Over three seeds: 0.868 ± 0.026 </a:t>
+            </a:r>
+            <a:r>
+              <a:rPr sz="1600" b="0" i="0">
                 <a:solidFill>
                   <a:srgbClr val="555555"/>
                 </a:solidFill>
                 <a:latin typeface="Times New Roman"/>
               </a:rPr>
-              <a:t>Removing alignment costs 0.074 on this cohort. Seven participants, nine sessions each, fitted on sessions 1–3 and tested on sessions 4–9 recorded weeks later.</a:t>
+              <a:t>(corrected estimator). The single-seed figure is the top of that range; two participants carry most of the variation.</a:t>
             </a:r>
           </a:p>
         </p:txBody>

</xml_diff>

<commit_message>
Deck, briefing and log: three-seed alignment effect on cohort A
Co-Authored-By: Claude Opus 5 (1M context) <noreply@anthropic.com>
</commit_message>
<xml_diff>
--- a/presentation/Updated_manuscript_presentation.pptx
+++ b/presentation/Updated_manuscript_presentation.pptx
@@ -5256,6 +5256,34 @@
                 <a:latin typeface="Times New Roman"/>
               </a:rPr>
               <a:t>Headline over three seeds is 0.868 ± 0.026; most other arms are single seed.</a:t>
+            </a:r>
+          </a:p>
+          <a:p>
+            <a:pPr algn="l">
+              <a:lnSpc>
+                <a:spcPct val="120000"/>
+              </a:lnSpc>
+              <a:spcAft>
+                <a:spcPts val="1000"/>
+              </a:spcAft>
+            </a:pPr>
+            <a:r>
+              <a:rPr sz="1600" b="1" i="0">
+                <a:solidFill>
+                  <a:srgbClr val="111111"/>
+                </a:solidFill>
+                <a:latin typeface="Times New Roman"/>
+              </a:rPr>
+              <a:t>•  </a:t>
+            </a:r>
+            <a:r>
+              <a:rPr sz="1600" b="0" i="0">
+                <a:solidFill>
+                  <a:srgbClr val="555555"/>
+                </a:solidFill>
+                <a:latin typeface="Times New Roman"/>
+              </a:rPr>
+              <a:t>Where the band holds, alignment's gain is small: +0.026 over three seeds on cohort A (p = 0.22).</a:t>
             </a:r>
           </a:p>
           <a:p>
@@ -9163,7 +9191,35 @@
                 </a:solidFill>
                 <a:latin typeface="Times New Roman"/>
               </a:rPr>
-              <a:t>Removing alignment costs 0.074 on this cohort. Seven participants, nine sessions each, fitted on sessions 1–3 and tested on sessions 4–9 recorded weeks later.</a:t>
+              <a:t>Seven participants, nine sessions each, fitted on sessions 1–3 and tested on sessions 4–9 recorded weeks later.</a:t>
+            </a:r>
+          </a:p>
+          <a:p>
+            <a:pPr algn="l">
+              <a:lnSpc>
+                <a:spcPct val="120000"/>
+              </a:lnSpc>
+              <a:spcAft>
+                <a:spcPts val="600"/>
+              </a:spcAft>
+            </a:pPr>
+            <a:r>
+              <a:rPr sz="1600" b="1" i="0">
+                <a:solidFill>
+                  <a:srgbClr val="111111"/>
+                </a:solidFill>
+                <a:latin typeface="Times New Roman"/>
+              </a:rPr>
+              <a:t>Over three seeds: 0.868 ± 0.026 </a:t>
+            </a:r>
+            <a:r>
+              <a:rPr sz="1600" b="0" i="0">
+                <a:solidFill>
+                  <a:srgbClr val="555555"/>
+                </a:solidFill>
+                <a:latin typeface="Times New Roman"/>
+              </a:rPr>
+              <a:t>(corrected estimator), the single-seed figure being the top of that range.</a:t>
             </a:r>
           </a:p>
           <a:p>
@@ -9182,7 +9238,7 @@
                 </a:solidFill>
                 <a:latin typeface="Times New Roman"/>
               </a:rPr>
-              <a:t>Over three seeds: 0.868 ± 0.026 </a:t>
+              <a:t>Alignment over three seeds: +0.026 </a:t>
             </a:r>
             <a:r>
               <a:rPr sz="1600" b="0" i="0">
@@ -9191,7 +9247,7 @@
                 </a:solidFill>
                 <a:latin typeface="Times New Roman"/>
               </a:rPr>
-              <a:t>(corrected estimator). The single-seed figure is the top of that range; two participants carry most of the variation.</a:t>
+              <a:t>against the gate-only arm (0.842), higher in 6 of 7 participants, p = 0.22. Positive on 2 seeds, negative on 1.</a:t>
             </a:r>
           </a:p>
         </p:txBody>
@@ -10415,7 +10471,7 @@
                 </a:solidFill>
                 <a:latin typeface="Times New Roman"/>
               </a:rPr>
-              <a:t>It adds 0.074 on cohort A and costs 0.211 on cohort B.</a:t>
+              <a:t>It adds 0.074 on cohort A at seed 0 (+0.026 over three seeds) and costs 0.211 on cohort B.</a:t>
             </a:r>
           </a:p>
         </p:txBody>

</xml_diff>